<commit_message>
Update final challenge deliverables
</commit_message>
<xml_diff>
--- a/Task3_Paper_Review/part3_mdpo_review_slides.pptx
+++ b/Task3_Paper_Review/part3_mdpo_review_slides.pptx
@@ -5,16 +5,16 @@
     <p:sldMasterId id="2147483648" r:id="rId1"/>
   </p:sldMasterIdLst>
   <p:sldIdLst>
-    <p:sldId id="256" r:id="rId7"/>
-    <p:sldId id="257" r:id="rId8"/>
-    <p:sldId id="258" r:id="rId9"/>
-    <p:sldId id="259" r:id="rId10"/>
-    <p:sldId id="260" r:id="rId11"/>
-    <p:sldId id="261" r:id="rId12"/>
-    <p:sldId id="262" r:id="rId13"/>
-    <p:sldId id="263" r:id="rId14"/>
+    <p:sldId id="256" r:id="rId2"/>
+    <p:sldId id="257" r:id="rId3"/>
+    <p:sldId id="258" r:id="rId4"/>
+    <p:sldId id="259" r:id="rId5"/>
+    <p:sldId id="260" r:id="rId6"/>
+    <p:sldId id="261" r:id="rId7"/>
+    <p:sldId id="262" r:id="rId8"/>
+    <p:sldId id="263" r:id="rId9"/>
   </p:sldIdLst>
-  <p:sldSz cx="12191695" cy="6858000" type="screen4x3"/>
+  <p:sldSz cx="12192000" cy="6858000"/>
   <p:notesSz cx="6858000" cy="9144000"/>
   <p:defaultTextStyle>
     <a:defPPr>
@@ -111,6 +111,22 @@
       </a:defRPr>
     </a:lvl9pPr>
   </p:defaultTextStyle>
+  <p:extLst>
+    <p:ext uri="{EFAFB233-063F-42B5-8137-9DF3F51BA10A}">
+      <p15:sldGuideLst xmlns:p15="http://schemas.microsoft.com/office/powerpoint/2012/main">
+        <p15:guide id="1" orient="horz" pos="2160">
+          <p15:clr>
+            <a:srgbClr val="A4A3A4"/>
+          </p15:clr>
+        </p15:guide>
+        <p15:guide id="2" pos="2880">
+          <p15:clr>
+            <a:srgbClr val="A4A3A4"/>
+          </p15:clr>
+        </p15:guide>
+      </p15:sldGuideLst>
+    </p:ext>
+  </p:extLst>
 </p:presentation>
 </file>
 
@@ -152,10 +168,9 @@
           <a:lstStyle/>
           <a:p>
             <a:r>
-              <a:rPr lang="en-US" smtClean="0"/>
+              <a:rPr lang="en-US"/>
               <a:t>Click to edit Master title style</a:t>
             </a:r>
-            <a:endParaRPr lang="en-US"/>
           </a:p>
         </p:txBody>
       </p:sp>
@@ -271,10 +286,9 @@
           </a:lstStyle>
           <a:p>
             <a:r>
-              <a:rPr lang="en-US" smtClean="0"/>
+              <a:rPr lang="en-US"/>
               <a:t>Click to edit Master subtitle style</a:t>
             </a:r>
-            <a:endParaRPr lang="en-US"/>
           </a:p>
         </p:txBody>
       </p:sp>
@@ -295,7 +309,7 @@
           <a:p>
             <a:fld id="{5BCAD085-E8A6-8845-BD4E-CB4CCA059FC4}" type="datetimeFigureOut">
               <a:rPr lang="en-US" smtClean="0"/>
-              <a:t>1/27/13</a:t>
+              <a:t>7/8/2026</a:t>
             </a:fld>
             <a:endParaRPr lang="en-US"/>
           </a:p>
@@ -389,10 +403,9 @@
           <a:lstStyle/>
           <a:p>
             <a:r>
-              <a:rPr lang="en-US" smtClean="0"/>
+              <a:rPr lang="en-US"/>
               <a:t>Click to edit Master title style</a:t>
             </a:r>
-            <a:endParaRPr lang="en-US"/>
           </a:p>
         </p:txBody>
       </p:sp>
@@ -413,38 +426,37 @@
           <a:p>
             <a:pPr lvl="0"/>
             <a:r>
-              <a:rPr lang="en-US" smtClean="0"/>
+              <a:rPr lang="en-US"/>
               <a:t>Click to edit Master text styles</a:t>
             </a:r>
           </a:p>
           <a:p>
             <a:pPr lvl="1"/>
             <a:r>
-              <a:rPr lang="en-US" smtClean="0"/>
+              <a:rPr lang="en-US"/>
               <a:t>Second level</a:t>
             </a:r>
           </a:p>
           <a:p>
             <a:pPr lvl="2"/>
             <a:r>
-              <a:rPr lang="en-US" smtClean="0"/>
+              <a:rPr lang="en-US"/>
               <a:t>Third level</a:t>
             </a:r>
           </a:p>
           <a:p>
             <a:pPr lvl="3"/>
             <a:r>
-              <a:rPr lang="en-US" smtClean="0"/>
+              <a:rPr lang="en-US"/>
               <a:t>Fourth level</a:t>
             </a:r>
           </a:p>
           <a:p>
             <a:pPr lvl="4"/>
             <a:r>
-              <a:rPr lang="en-US" smtClean="0"/>
+              <a:rPr lang="en-US"/>
               <a:t>Fifth level</a:t>
             </a:r>
-            <a:endParaRPr lang="en-US"/>
           </a:p>
         </p:txBody>
       </p:sp>
@@ -465,7 +477,7 @@
           <a:p>
             <a:fld id="{5BCAD085-E8A6-8845-BD4E-CB4CCA059FC4}" type="datetimeFigureOut">
               <a:rPr lang="en-US" smtClean="0"/>
-              <a:t>1/27/13</a:t>
+              <a:t>7/8/2026</a:t>
             </a:fld>
             <a:endParaRPr lang="en-US"/>
           </a:p>
@@ -564,10 +576,9 @@
           <a:lstStyle/>
           <a:p>
             <a:r>
-              <a:rPr lang="en-US" smtClean="0"/>
+              <a:rPr lang="en-US"/>
               <a:t>Click to edit Master title style</a:t>
             </a:r>
-            <a:endParaRPr lang="en-US"/>
           </a:p>
         </p:txBody>
       </p:sp>
@@ -593,38 +604,37 @@
           <a:p>
             <a:pPr lvl="0"/>
             <a:r>
-              <a:rPr lang="en-US" smtClean="0"/>
+              <a:rPr lang="en-US"/>
               <a:t>Click to edit Master text styles</a:t>
             </a:r>
           </a:p>
           <a:p>
             <a:pPr lvl="1"/>
             <a:r>
-              <a:rPr lang="en-US" smtClean="0"/>
+              <a:rPr lang="en-US"/>
               <a:t>Second level</a:t>
             </a:r>
           </a:p>
           <a:p>
             <a:pPr lvl="2"/>
             <a:r>
-              <a:rPr lang="en-US" smtClean="0"/>
+              <a:rPr lang="en-US"/>
               <a:t>Third level</a:t>
             </a:r>
           </a:p>
           <a:p>
             <a:pPr lvl="3"/>
             <a:r>
-              <a:rPr lang="en-US" smtClean="0"/>
+              <a:rPr lang="en-US"/>
               <a:t>Fourth level</a:t>
             </a:r>
           </a:p>
           <a:p>
             <a:pPr lvl="4"/>
             <a:r>
-              <a:rPr lang="en-US" smtClean="0"/>
+              <a:rPr lang="en-US"/>
               <a:t>Fifth level</a:t>
             </a:r>
-            <a:endParaRPr lang="en-US"/>
           </a:p>
         </p:txBody>
       </p:sp>
@@ -645,7 +655,7 @@
           <a:p>
             <a:fld id="{5BCAD085-E8A6-8845-BD4E-CB4CCA059FC4}" type="datetimeFigureOut">
               <a:rPr lang="en-US" smtClean="0"/>
-              <a:t>1/27/13</a:t>
+              <a:t>7/8/2026</a:t>
             </a:fld>
             <a:endParaRPr lang="en-US"/>
           </a:p>
@@ -739,10 +749,9 @@
           <a:lstStyle/>
           <a:p>
             <a:r>
-              <a:rPr lang="en-US" smtClean="0"/>
+              <a:rPr lang="en-US"/>
               <a:t>Click to edit Master title style</a:t>
             </a:r>
-            <a:endParaRPr lang="en-US"/>
           </a:p>
         </p:txBody>
       </p:sp>
@@ -763,38 +772,37 @@
           <a:p>
             <a:pPr lvl="0"/>
             <a:r>
-              <a:rPr lang="en-US" smtClean="0"/>
+              <a:rPr lang="en-US"/>
               <a:t>Click to edit Master text styles</a:t>
             </a:r>
           </a:p>
           <a:p>
             <a:pPr lvl="1"/>
             <a:r>
-              <a:rPr lang="en-US" smtClean="0"/>
+              <a:rPr lang="en-US"/>
               <a:t>Second level</a:t>
             </a:r>
           </a:p>
           <a:p>
             <a:pPr lvl="2"/>
             <a:r>
-              <a:rPr lang="en-US" smtClean="0"/>
+              <a:rPr lang="en-US"/>
               <a:t>Third level</a:t>
             </a:r>
           </a:p>
           <a:p>
             <a:pPr lvl="3"/>
             <a:r>
-              <a:rPr lang="en-US" smtClean="0"/>
+              <a:rPr lang="en-US"/>
               <a:t>Fourth level</a:t>
             </a:r>
           </a:p>
           <a:p>
             <a:pPr lvl="4"/>
             <a:r>
-              <a:rPr lang="en-US" smtClean="0"/>
+              <a:rPr lang="en-US"/>
               <a:t>Fifth level</a:t>
             </a:r>
-            <a:endParaRPr lang="en-US"/>
           </a:p>
         </p:txBody>
       </p:sp>
@@ -815,7 +823,7 @@
           <a:p>
             <a:fld id="{5BCAD085-E8A6-8845-BD4E-CB4CCA059FC4}" type="datetimeFigureOut">
               <a:rPr lang="en-US" smtClean="0"/>
-              <a:t>1/27/13</a:t>
+              <a:t>7/8/2026</a:t>
             </a:fld>
             <a:endParaRPr lang="en-US"/>
           </a:p>
@@ -918,10 +926,9 @@
           </a:lstStyle>
           <a:p>
             <a:r>
-              <a:rPr lang="en-US" smtClean="0"/>
+              <a:rPr lang="en-US"/>
               <a:t>Click to edit Master title style</a:t>
             </a:r>
-            <a:endParaRPr lang="en-US"/>
           </a:p>
         </p:txBody>
       </p:sp>
@@ -1038,7 +1045,7 @@
           <a:p>
             <a:pPr lvl="0"/>
             <a:r>
-              <a:rPr lang="en-US" smtClean="0"/>
+              <a:rPr lang="en-US"/>
               <a:t>Click to edit Master text styles</a:t>
             </a:r>
           </a:p>
@@ -1061,7 +1068,7 @@
           <a:p>
             <a:fld id="{5BCAD085-E8A6-8845-BD4E-CB4CCA059FC4}" type="datetimeFigureOut">
               <a:rPr lang="en-US" smtClean="0"/>
-              <a:t>1/27/13</a:t>
+              <a:t>7/8/2026</a:t>
             </a:fld>
             <a:endParaRPr lang="en-US"/>
           </a:p>
@@ -1155,10 +1162,9 @@
           <a:lstStyle/>
           <a:p>
             <a:r>
-              <a:rPr lang="en-US" smtClean="0"/>
+              <a:rPr lang="en-US"/>
               <a:t>Click to edit Master title style</a:t>
             </a:r>
-            <a:endParaRPr lang="en-US"/>
           </a:p>
         </p:txBody>
       </p:sp>
@@ -1212,38 +1218,37 @@
           <a:p>
             <a:pPr lvl="0"/>
             <a:r>
-              <a:rPr lang="en-US" smtClean="0"/>
+              <a:rPr lang="en-US"/>
               <a:t>Click to edit Master text styles</a:t>
             </a:r>
           </a:p>
           <a:p>
             <a:pPr lvl="1"/>
             <a:r>
-              <a:rPr lang="en-US" smtClean="0"/>
+              <a:rPr lang="en-US"/>
               <a:t>Second level</a:t>
             </a:r>
           </a:p>
           <a:p>
             <a:pPr lvl="2"/>
             <a:r>
-              <a:rPr lang="en-US" smtClean="0"/>
+              <a:rPr lang="en-US"/>
               <a:t>Third level</a:t>
             </a:r>
           </a:p>
           <a:p>
             <a:pPr lvl="3"/>
             <a:r>
-              <a:rPr lang="en-US" smtClean="0"/>
+              <a:rPr lang="en-US"/>
               <a:t>Fourth level</a:t>
             </a:r>
           </a:p>
           <a:p>
             <a:pPr lvl="4"/>
             <a:r>
-              <a:rPr lang="en-US" smtClean="0"/>
+              <a:rPr lang="en-US"/>
               <a:t>Fifth level</a:t>
             </a:r>
-            <a:endParaRPr lang="en-US"/>
           </a:p>
         </p:txBody>
       </p:sp>
@@ -1297,38 +1302,37 @@
           <a:p>
             <a:pPr lvl="0"/>
             <a:r>
-              <a:rPr lang="en-US" smtClean="0"/>
+              <a:rPr lang="en-US"/>
               <a:t>Click to edit Master text styles</a:t>
             </a:r>
           </a:p>
           <a:p>
             <a:pPr lvl="1"/>
             <a:r>
-              <a:rPr lang="en-US" smtClean="0"/>
+              <a:rPr lang="en-US"/>
               <a:t>Second level</a:t>
             </a:r>
           </a:p>
           <a:p>
             <a:pPr lvl="2"/>
             <a:r>
-              <a:rPr lang="en-US" smtClean="0"/>
+              <a:rPr lang="en-US"/>
               <a:t>Third level</a:t>
             </a:r>
           </a:p>
           <a:p>
             <a:pPr lvl="3"/>
             <a:r>
-              <a:rPr lang="en-US" smtClean="0"/>
+              <a:rPr lang="en-US"/>
               <a:t>Fourth level</a:t>
             </a:r>
           </a:p>
           <a:p>
             <a:pPr lvl="4"/>
             <a:r>
-              <a:rPr lang="en-US" smtClean="0"/>
+              <a:rPr lang="en-US"/>
               <a:t>Fifth level</a:t>
             </a:r>
-            <a:endParaRPr lang="en-US"/>
           </a:p>
         </p:txBody>
       </p:sp>
@@ -1349,7 +1353,7 @@
           <a:p>
             <a:fld id="{5BCAD085-E8A6-8845-BD4E-CB4CCA059FC4}" type="datetimeFigureOut">
               <a:rPr lang="en-US" smtClean="0"/>
-              <a:t>1/27/13</a:t>
+              <a:t>7/8/2026</a:t>
             </a:fld>
             <a:endParaRPr lang="en-US"/>
           </a:p>
@@ -1447,10 +1451,9 @@
           </a:lstStyle>
           <a:p>
             <a:r>
-              <a:rPr lang="en-US" smtClean="0"/>
+              <a:rPr lang="en-US"/>
               <a:t>Click to edit Master title style</a:t>
             </a:r>
-            <a:endParaRPr lang="en-US"/>
           </a:p>
         </p:txBody>
       </p:sp>
@@ -1513,7 +1516,7 @@
           <a:p>
             <a:pPr lvl="0"/>
             <a:r>
-              <a:rPr lang="en-US" smtClean="0"/>
+              <a:rPr lang="en-US"/>
               <a:t>Click to edit Master text styles</a:t>
             </a:r>
           </a:p>
@@ -1569,38 +1572,37 @@
           <a:p>
             <a:pPr lvl="0"/>
             <a:r>
-              <a:rPr lang="en-US" smtClean="0"/>
+              <a:rPr lang="en-US"/>
               <a:t>Click to edit Master text styles</a:t>
             </a:r>
           </a:p>
           <a:p>
             <a:pPr lvl="1"/>
             <a:r>
-              <a:rPr lang="en-US" smtClean="0"/>
+              <a:rPr lang="en-US"/>
               <a:t>Second level</a:t>
             </a:r>
           </a:p>
           <a:p>
             <a:pPr lvl="2"/>
             <a:r>
-              <a:rPr lang="en-US" smtClean="0"/>
+              <a:rPr lang="en-US"/>
               <a:t>Third level</a:t>
             </a:r>
           </a:p>
           <a:p>
             <a:pPr lvl="3"/>
             <a:r>
-              <a:rPr lang="en-US" smtClean="0"/>
+              <a:rPr lang="en-US"/>
               <a:t>Fourth level</a:t>
             </a:r>
           </a:p>
           <a:p>
             <a:pPr lvl="4"/>
             <a:r>
-              <a:rPr lang="en-US" smtClean="0"/>
+              <a:rPr lang="en-US"/>
               <a:t>Fifth level</a:t>
             </a:r>
-            <a:endParaRPr lang="en-US"/>
           </a:p>
         </p:txBody>
       </p:sp>
@@ -1663,7 +1665,7 @@
           <a:p>
             <a:pPr lvl="0"/>
             <a:r>
-              <a:rPr lang="en-US" smtClean="0"/>
+              <a:rPr lang="en-US"/>
               <a:t>Click to edit Master text styles</a:t>
             </a:r>
           </a:p>
@@ -1719,38 +1721,37 @@
           <a:p>
             <a:pPr lvl="0"/>
             <a:r>
-              <a:rPr lang="en-US" smtClean="0"/>
+              <a:rPr lang="en-US"/>
               <a:t>Click to edit Master text styles</a:t>
             </a:r>
           </a:p>
           <a:p>
             <a:pPr lvl="1"/>
             <a:r>
-              <a:rPr lang="en-US" smtClean="0"/>
+              <a:rPr lang="en-US"/>
               <a:t>Second level</a:t>
             </a:r>
           </a:p>
           <a:p>
             <a:pPr lvl="2"/>
             <a:r>
-              <a:rPr lang="en-US" smtClean="0"/>
+              <a:rPr lang="en-US"/>
               <a:t>Third level</a:t>
             </a:r>
           </a:p>
           <a:p>
             <a:pPr lvl="3"/>
             <a:r>
-              <a:rPr lang="en-US" smtClean="0"/>
+              <a:rPr lang="en-US"/>
               <a:t>Fourth level</a:t>
             </a:r>
           </a:p>
           <a:p>
             <a:pPr lvl="4"/>
             <a:r>
-              <a:rPr lang="en-US" smtClean="0"/>
+              <a:rPr lang="en-US"/>
               <a:t>Fifth level</a:t>
             </a:r>
-            <a:endParaRPr lang="en-US"/>
           </a:p>
         </p:txBody>
       </p:sp>
@@ -1771,7 +1772,7 @@
           <a:p>
             <a:fld id="{5BCAD085-E8A6-8845-BD4E-CB4CCA059FC4}" type="datetimeFigureOut">
               <a:rPr lang="en-US" smtClean="0"/>
-              <a:t>1/27/13</a:t>
+              <a:t>7/8/2026</a:t>
             </a:fld>
             <a:endParaRPr lang="en-US"/>
           </a:p>
@@ -1865,10 +1866,9 @@
           <a:lstStyle/>
           <a:p>
             <a:r>
-              <a:rPr lang="en-US" smtClean="0"/>
+              <a:rPr lang="en-US"/>
               <a:t>Click to edit Master title style</a:t>
             </a:r>
-            <a:endParaRPr lang="en-US"/>
           </a:p>
         </p:txBody>
       </p:sp>
@@ -1889,7 +1889,7 @@
           <a:p>
             <a:fld id="{5BCAD085-E8A6-8845-BD4E-CB4CCA059FC4}" type="datetimeFigureOut">
               <a:rPr lang="en-US" smtClean="0"/>
-              <a:t>1/27/13</a:t>
+              <a:t>7/8/2026</a:t>
             </a:fld>
             <a:endParaRPr lang="en-US"/>
           </a:p>
@@ -1984,7 +1984,7 @@
           <a:p>
             <a:fld id="{5BCAD085-E8A6-8845-BD4E-CB4CCA059FC4}" type="datetimeFigureOut">
               <a:rPr lang="en-US" smtClean="0"/>
-              <a:t>1/27/13</a:t>
+              <a:t>7/8/2026</a:t>
             </a:fld>
             <a:endParaRPr lang="en-US"/>
           </a:p>
@@ -2087,10 +2087,9 @@
           </a:lstStyle>
           <a:p>
             <a:r>
-              <a:rPr lang="en-US" smtClean="0"/>
+              <a:rPr lang="en-US"/>
               <a:t>Click to edit Master title style</a:t>
             </a:r>
-            <a:endParaRPr lang="en-US"/>
           </a:p>
         </p:txBody>
       </p:sp>
@@ -2144,38 +2143,37 @@
           <a:p>
             <a:pPr lvl="0"/>
             <a:r>
-              <a:rPr lang="en-US" smtClean="0"/>
+              <a:rPr lang="en-US"/>
               <a:t>Click to edit Master text styles</a:t>
             </a:r>
           </a:p>
           <a:p>
             <a:pPr lvl="1"/>
             <a:r>
-              <a:rPr lang="en-US" smtClean="0"/>
+              <a:rPr lang="en-US"/>
               <a:t>Second level</a:t>
             </a:r>
           </a:p>
           <a:p>
             <a:pPr lvl="2"/>
             <a:r>
-              <a:rPr lang="en-US" smtClean="0"/>
+              <a:rPr lang="en-US"/>
               <a:t>Third level</a:t>
             </a:r>
           </a:p>
           <a:p>
             <a:pPr lvl="3"/>
             <a:r>
-              <a:rPr lang="en-US" smtClean="0"/>
+              <a:rPr lang="en-US"/>
               <a:t>Fourth level</a:t>
             </a:r>
           </a:p>
           <a:p>
             <a:pPr lvl="4"/>
             <a:r>
-              <a:rPr lang="en-US" smtClean="0"/>
+              <a:rPr lang="en-US"/>
               <a:t>Fifth level</a:t>
             </a:r>
-            <a:endParaRPr lang="en-US"/>
           </a:p>
         </p:txBody>
       </p:sp>
@@ -2238,7 +2236,7 @@
           <a:p>
             <a:pPr lvl="0"/>
             <a:r>
-              <a:rPr lang="en-US" smtClean="0"/>
+              <a:rPr lang="en-US"/>
               <a:t>Click to edit Master text styles</a:t>
             </a:r>
           </a:p>
@@ -2261,7 +2259,7 @@
           <a:p>
             <a:fld id="{5BCAD085-E8A6-8845-BD4E-CB4CCA059FC4}" type="datetimeFigureOut">
               <a:rPr lang="en-US" smtClean="0"/>
-              <a:t>1/27/13</a:t>
+              <a:t>7/8/2026</a:t>
             </a:fld>
             <a:endParaRPr lang="en-US"/>
           </a:p>
@@ -2364,10 +2362,9 @@
           </a:lstStyle>
           <a:p>
             <a:r>
-              <a:rPr lang="en-US" smtClean="0"/>
+              <a:rPr lang="en-US"/>
               <a:t>Click to edit Master title style</a:t>
             </a:r>
-            <a:endParaRPr lang="en-US"/>
           </a:p>
         </p:txBody>
       </p:sp>
@@ -2491,7 +2488,7 @@
           <a:p>
             <a:pPr lvl="0"/>
             <a:r>
-              <a:rPr lang="en-US" smtClean="0"/>
+              <a:rPr lang="en-US"/>
               <a:t>Click to edit Master text styles</a:t>
             </a:r>
           </a:p>
@@ -2514,7 +2511,7 @@
           <a:p>
             <a:fld id="{5BCAD085-E8A6-8845-BD4E-CB4CCA059FC4}" type="datetimeFigureOut">
               <a:rPr lang="en-US" smtClean="0"/>
-              <a:t>1/27/13</a:t>
+              <a:t>7/8/2026</a:t>
             </a:fld>
             <a:endParaRPr lang="en-US"/>
           </a:p>
@@ -2623,10 +2620,9 @@
           <a:lstStyle/>
           <a:p>
             <a:r>
-              <a:rPr lang="en-US" smtClean="0"/>
+              <a:rPr lang="en-US"/>
               <a:t>Click to edit Master title style</a:t>
             </a:r>
-            <a:endParaRPr lang="en-US"/>
           </a:p>
         </p:txBody>
       </p:sp>
@@ -2657,38 +2653,37 @@
           <a:p>
             <a:pPr lvl="0"/>
             <a:r>
-              <a:rPr lang="en-US" smtClean="0"/>
+              <a:rPr lang="en-US"/>
               <a:t>Click to edit Master text styles</a:t>
             </a:r>
           </a:p>
           <a:p>
             <a:pPr lvl="1"/>
             <a:r>
-              <a:rPr lang="en-US" smtClean="0"/>
+              <a:rPr lang="en-US"/>
               <a:t>Second level</a:t>
             </a:r>
           </a:p>
           <a:p>
             <a:pPr lvl="2"/>
             <a:r>
-              <a:rPr lang="en-US" smtClean="0"/>
+              <a:rPr lang="en-US"/>
               <a:t>Third level</a:t>
             </a:r>
           </a:p>
           <a:p>
             <a:pPr lvl="3"/>
             <a:r>
-              <a:rPr lang="en-US" smtClean="0"/>
+              <a:rPr lang="en-US"/>
               <a:t>Fourth level</a:t>
             </a:r>
           </a:p>
           <a:p>
             <a:pPr lvl="4"/>
             <a:r>
-              <a:rPr lang="en-US" smtClean="0"/>
+              <a:rPr lang="en-US"/>
               <a:t>Fifth level</a:t>
             </a:r>
-            <a:endParaRPr lang="en-US"/>
           </a:p>
         </p:txBody>
       </p:sp>
@@ -2727,7 +2722,7 @@
           <a:p>
             <a:fld id="{5BCAD085-E8A6-8845-BD4E-CB4CCA059FC4}" type="datetimeFigureOut">
               <a:rPr lang="en-US" smtClean="0"/>
-              <a:t>1/27/13</a:t>
+              <a:t>7/8/2026</a:t>
             </a:fld>
             <a:endParaRPr lang="en-US"/>
           </a:p>
@@ -3086,7 +3081,7 @@
 </file>
 
 <file path=ppt/slides/slide1.xml><?xml version="1.0" encoding="utf-8"?>
-<p:sld xmlns:a="http://schemas.openxmlformats.org/drawingml/2006/main" xmlns:p="http://schemas.openxmlformats.org/presentationml/2006/main" xmlns:r="http://schemas.openxmlformats.org/officeDocument/2006/relationships">
+<p:sld xmlns:a="http://schemas.openxmlformats.org/drawingml/2006/main" xmlns:r="http://schemas.openxmlformats.org/officeDocument/2006/relationships" xmlns:p="http://schemas.openxmlformats.org/presentationml/2006/main">
   <p:cSld>
     <p:bg>
       <p:bgPr>
@@ -3102,7 +3097,14 @@
         <p:cNvGrpSpPr/>
         <p:nvPr/>
       </p:nvGrpSpPr>
-      <p:grpSpPr/>
+      <p:grpSpPr>
+        <a:xfrm>
+          <a:off x="0" y="0"/>
+          <a:ext cx="0" cy="0"/>
+          <a:chOff x="0" y="0"/>
+          <a:chExt cx="0" cy="0"/>
+        </a:xfrm>
+      </p:grpSpPr>
       <p:sp>
         <p:nvSpPr>
           <p:cNvPr id="2" name="TextBox 1"/>
@@ -3147,7 +3149,7 @@
         <p:spPr>
           <a:xfrm>
             <a:off x="658368" y="1143000"/>
-            <a:ext cx="9692640" cy="914400"/>
+            <a:ext cx="11299888" cy="1077218"/>
           </a:xfrm>
           <a:prstGeom prst="rect">
             <a:avLst/>
@@ -3168,7 +3170,22 @@
               </a:defRPr>
             </a:pPr>
             <a:r>
-              <a:t>MDPO: Conditional Preference Optimization for Multimodal Large Language Models</a:t>
+              <a:rPr dirty="0"/>
+              <a:t>MDPO: Conditional Preference Optimization for Multimodal Large</a:t>
+            </a:r>
+            <a:endParaRPr lang="en-US" dirty="0"/>
+          </a:p>
+          <a:p>
+            <a:pPr algn="l">
+              <a:defRPr sz="3200" b="1">
+                <a:solidFill>
+                  <a:srgbClr val="162236"/>
+                </a:solidFill>
+              </a:defRPr>
+            </a:pPr>
+            <a:r>
+              <a:rPr dirty="0"/>
+              <a:t> Language Models</a:t>
             </a:r>
           </a:p>
         </p:txBody>
@@ -3285,6 +3302,7 @@
           <a:lstStyle/>
           <a:p>
             <a:pPr algn="ctr"/>
+            <a:endParaRPr/>
           </a:p>
         </p:txBody>
       </p:sp>
@@ -3365,6 +3383,7 @@
           <a:lstStyle/>
           <a:p>
             <a:pPr algn="ctr"/>
+            <a:endParaRPr/>
           </a:p>
         </p:txBody>
       </p:sp>
@@ -3410,6 +3429,7 @@
           <a:lstStyle/>
           <a:p>
             <a:pPr algn="ctr"/>
+            <a:endParaRPr/>
           </a:p>
         </p:txBody>
       </p:sp>
@@ -3565,7 +3585,7 @@
 </file>
 
 <file path=ppt/slides/slide2.xml><?xml version="1.0" encoding="utf-8"?>
-<p:sld xmlns:a="http://schemas.openxmlformats.org/drawingml/2006/main" xmlns:p="http://schemas.openxmlformats.org/presentationml/2006/main" xmlns:r="http://schemas.openxmlformats.org/officeDocument/2006/relationships">
+<p:sld xmlns:a="http://schemas.openxmlformats.org/drawingml/2006/main" xmlns:r="http://schemas.openxmlformats.org/officeDocument/2006/relationships" xmlns:p="http://schemas.openxmlformats.org/presentationml/2006/main">
   <p:cSld>
     <p:bg>
       <p:bgPr>
@@ -3581,7 +3601,14 @@
         <p:cNvGrpSpPr/>
         <p:nvPr/>
       </p:nvGrpSpPr>
-      <p:grpSpPr/>
+      <p:grpSpPr>
+        <a:xfrm>
+          <a:off x="0" y="0"/>
+          <a:ext cx="0" cy="0"/>
+          <a:chOff x="0" y="0"/>
+          <a:chExt cx="0" cy="0"/>
+        </a:xfrm>
+      </p:grpSpPr>
       <p:sp>
         <p:nvSpPr>
           <p:cNvPr id="2" name="TextBox 1"/>
@@ -3694,6 +3721,7 @@
           <a:lstStyle/>
           <a:p>
             <a:pPr algn="ctr"/>
+            <a:endParaRPr/>
           </a:p>
         </p:txBody>
       </p:sp>
@@ -3739,6 +3767,7 @@
           <a:lstStyle/>
           <a:p>
             <a:pPr algn="ctr"/>
+            <a:endParaRPr/>
           </a:p>
         </p:txBody>
       </p:sp>
@@ -3784,6 +3813,7 @@
           <a:lstStyle/>
           <a:p>
             <a:pPr algn="ctr"/>
+            <a:endParaRPr/>
           </a:p>
         </p:txBody>
       </p:sp>
@@ -3917,6 +3947,7 @@
           <a:lstStyle/>
           <a:p>
             <a:pPr algn="ctr"/>
+            <a:endParaRPr/>
           </a:p>
         </p:txBody>
       </p:sp>
@@ -3962,6 +3993,7 @@
           <a:lstStyle/>
           <a:p>
             <a:pPr algn="ctr"/>
+            <a:endParaRPr/>
           </a:p>
         </p:txBody>
       </p:sp>
@@ -4095,6 +4127,7 @@
           <a:lstStyle/>
           <a:p>
             <a:pPr algn="ctr"/>
+            <a:endParaRPr/>
           </a:p>
         </p:txBody>
       </p:sp>
@@ -4140,6 +4173,7 @@
           <a:lstStyle/>
           <a:p>
             <a:pPr algn="ctr"/>
+            <a:endParaRPr/>
           </a:p>
         </p:txBody>
       </p:sp>
@@ -4310,7 +4344,7 @@
 </file>
 
 <file path=ppt/slides/slide3.xml><?xml version="1.0" encoding="utf-8"?>
-<p:sld xmlns:a="http://schemas.openxmlformats.org/drawingml/2006/main" xmlns:p="http://schemas.openxmlformats.org/presentationml/2006/main" xmlns:r="http://schemas.openxmlformats.org/officeDocument/2006/relationships">
+<p:sld xmlns:a="http://schemas.openxmlformats.org/drawingml/2006/main" xmlns:r="http://schemas.openxmlformats.org/officeDocument/2006/relationships" xmlns:p="http://schemas.openxmlformats.org/presentationml/2006/main">
   <p:cSld>
     <p:bg>
       <p:bgPr>
@@ -4326,7 +4360,14 @@
         <p:cNvGrpSpPr/>
         <p:nvPr/>
       </p:nvGrpSpPr>
-      <p:grpSpPr/>
+      <p:grpSpPr>
+        <a:xfrm>
+          <a:off x="0" y="0"/>
+          <a:ext cx="0" cy="0"/>
+          <a:chOff x="0" y="0"/>
+          <a:chExt cx="0" cy="0"/>
+        </a:xfrm>
+      </p:grpSpPr>
       <p:sp>
         <p:nvSpPr>
           <p:cNvPr id="2" name="TextBox 1"/>
@@ -4439,6 +4480,7 @@
           <a:lstStyle/>
           <a:p>
             <a:pPr algn="ctr"/>
+            <a:endParaRPr/>
           </a:p>
         </p:txBody>
       </p:sp>
@@ -4589,6 +4631,7 @@
           <a:lstStyle/>
           <a:p>
             <a:pPr algn="ctr"/>
+            <a:endParaRPr/>
           </a:p>
         </p:txBody>
       </p:sp>
@@ -4673,6 +4716,7 @@
           <a:lstStyle/>
           <a:p>
             <a:pPr algn="ctr"/>
+            <a:endParaRPr/>
           </a:p>
         </p:txBody>
       </p:sp>
@@ -4757,6 +4801,7 @@
           <a:lstStyle/>
           <a:p>
             <a:pPr algn="ctr"/>
+            <a:endParaRPr/>
           </a:p>
         </p:txBody>
       </p:sp>
@@ -4878,7 +4923,7 @@
         <p:spPr>
           <a:xfrm>
             <a:off x="914400" y="4224528"/>
-            <a:ext cx="10424160" cy="713232"/>
+            <a:ext cx="10730053" cy="646331"/>
           </a:xfrm>
           <a:prstGeom prst="rect">
             <a:avLst/>
@@ -4899,7 +4944,22 @@
               </a:defRPr>
             </a:pPr>
             <a:r>
-              <a:t>Reviewer take: this diagnostic is strong because it isolates the failure mode. If removing images barely hurts DPO, the objective is not reliably enforcing multimodal conditioning.</a:t>
+              <a:rPr dirty="0"/>
+              <a:t>Reviewer take: this diagnostic is strong because it isolates the failure mode. If removing images barely hurts DPO, </a:t>
+            </a:r>
+            <a:endParaRPr lang="en-US" dirty="0"/>
+          </a:p>
+          <a:p>
+            <a:pPr algn="l">
+              <a:defRPr sz="1800" b="0">
+                <a:solidFill>
+                  <a:srgbClr val="23272F"/>
+                </a:solidFill>
+              </a:defRPr>
+            </a:pPr>
+            <a:r>
+              <a:rPr dirty="0"/>
+              <a:t>the objective is not reliably enforcing multimodal conditioning.</a:t>
             </a:r>
           </a:p>
         </p:txBody>
@@ -4983,7 +5043,7 @@
 </file>
 
 <file path=ppt/slides/slide4.xml><?xml version="1.0" encoding="utf-8"?>
-<p:sld xmlns:a="http://schemas.openxmlformats.org/drawingml/2006/main" xmlns:p="http://schemas.openxmlformats.org/presentationml/2006/main" xmlns:r="http://schemas.openxmlformats.org/officeDocument/2006/relationships">
+<p:sld xmlns:a="http://schemas.openxmlformats.org/drawingml/2006/main" xmlns:r="http://schemas.openxmlformats.org/officeDocument/2006/relationships" xmlns:p="http://schemas.openxmlformats.org/presentationml/2006/main">
   <p:cSld>
     <p:bg>
       <p:bgPr>
@@ -4999,7 +5059,14 @@
         <p:cNvGrpSpPr/>
         <p:nvPr/>
       </p:nvGrpSpPr>
-      <p:grpSpPr/>
+      <p:grpSpPr>
+        <a:xfrm>
+          <a:off x="0" y="0"/>
+          <a:ext cx="0" cy="0"/>
+          <a:chOff x="0" y="0"/>
+          <a:chExt cx="0" cy="0"/>
+        </a:xfrm>
+      </p:grpSpPr>
       <p:sp>
         <p:nvSpPr>
           <p:cNvPr id="2" name="TextBox 1"/>
@@ -5112,6 +5179,7 @@
           <a:lstStyle/>
           <a:p>
             <a:pPr algn="ctr"/>
+            <a:endParaRPr/>
           </a:p>
         </p:txBody>
       </p:sp>
@@ -5157,6 +5225,7 @@
           <a:lstStyle/>
           <a:p>
             <a:pPr algn="ctr"/>
+            <a:endParaRPr/>
           </a:p>
         </p:txBody>
       </p:sp>
@@ -5202,6 +5271,7 @@
           <a:lstStyle/>
           <a:p>
             <a:pPr algn="ctr"/>
+            <a:endParaRPr/>
           </a:p>
         </p:txBody>
       </p:sp>
@@ -5335,6 +5405,7 @@
           <a:lstStyle/>
           <a:p>
             <a:pPr algn="ctr"/>
+            <a:endParaRPr/>
           </a:p>
         </p:txBody>
       </p:sp>
@@ -5380,6 +5451,7 @@
           <a:lstStyle/>
           <a:p>
             <a:pPr algn="ctr"/>
+            <a:endParaRPr/>
           </a:p>
         </p:txBody>
       </p:sp>
@@ -5528,6 +5600,7 @@
           <a:lstStyle/>
           <a:p>
             <a:pPr algn="ctr"/>
+            <a:endParaRPr/>
           </a:p>
         </p:txBody>
       </p:sp>
@@ -5573,6 +5646,7 @@
           <a:lstStyle/>
           <a:p>
             <a:pPr algn="ctr"/>
+            <a:endParaRPr/>
           </a:p>
         </p:txBody>
       </p:sp>
@@ -5778,7 +5852,7 @@
 </file>
 
 <file path=ppt/slides/slide5.xml><?xml version="1.0" encoding="utf-8"?>
-<p:sld xmlns:a="http://schemas.openxmlformats.org/drawingml/2006/main" xmlns:p="http://schemas.openxmlformats.org/presentationml/2006/main" xmlns:r="http://schemas.openxmlformats.org/officeDocument/2006/relationships">
+<p:sld xmlns:a="http://schemas.openxmlformats.org/drawingml/2006/main" xmlns:r="http://schemas.openxmlformats.org/officeDocument/2006/relationships" xmlns:p="http://schemas.openxmlformats.org/presentationml/2006/main">
   <p:cSld>
     <p:bg>
       <p:bgPr>
@@ -5794,7 +5868,14 @@
         <p:cNvGrpSpPr/>
         <p:nvPr/>
       </p:nvGrpSpPr>
-      <p:grpSpPr/>
+      <p:grpSpPr>
+        <a:xfrm>
+          <a:off x="0" y="0"/>
+          <a:ext cx="0" cy="0"/>
+          <a:chOff x="0" y="0"/>
+          <a:chExt cx="0" cy="0"/>
+        </a:xfrm>
+      </p:grpSpPr>
       <p:sp>
         <p:nvSpPr>
           <p:cNvPr id="2" name="TextBox 1"/>
@@ -5907,6 +5988,7 @@
           <a:lstStyle/>
           <a:p>
             <a:pPr algn="ctr"/>
+            <a:endParaRPr/>
           </a:p>
         </p:txBody>
       </p:sp>
@@ -5952,6 +6034,7 @@
           <a:lstStyle/>
           <a:p>
             <a:pPr algn="ctr"/>
+            <a:endParaRPr/>
           </a:p>
         </p:txBody>
       </p:sp>
@@ -5997,6 +6080,7 @@
           <a:lstStyle/>
           <a:p>
             <a:pPr algn="ctr"/>
+            <a:endParaRPr/>
           </a:p>
         </p:txBody>
       </p:sp>
@@ -6145,6 +6229,7 @@
           <a:lstStyle/>
           <a:p>
             <a:pPr algn="ctr"/>
+            <a:endParaRPr/>
           </a:p>
         </p:txBody>
       </p:sp>
@@ -6190,6 +6275,7 @@
           <a:lstStyle/>
           <a:p>
             <a:pPr algn="ctr"/>
+            <a:endParaRPr/>
           </a:p>
         </p:txBody>
       </p:sp>
@@ -6323,6 +6409,7 @@
           <a:lstStyle/>
           <a:p>
             <a:pPr algn="ctr"/>
+            <a:endParaRPr/>
           </a:p>
         </p:txBody>
       </p:sp>
@@ -6368,6 +6455,7 @@
           <a:lstStyle/>
           <a:p>
             <a:pPr algn="ctr"/>
+            <a:endParaRPr/>
           </a:p>
         </p:txBody>
       </p:sp>
@@ -6603,7 +6691,7 @@
 </file>
 
 <file path=ppt/slides/slide6.xml><?xml version="1.0" encoding="utf-8"?>
-<p:sld xmlns:a="http://schemas.openxmlformats.org/drawingml/2006/main" xmlns:p="http://schemas.openxmlformats.org/presentationml/2006/main" xmlns:r="http://schemas.openxmlformats.org/officeDocument/2006/relationships">
+<p:sld xmlns:a="http://schemas.openxmlformats.org/drawingml/2006/main" xmlns:r="http://schemas.openxmlformats.org/officeDocument/2006/relationships" xmlns:p="http://schemas.openxmlformats.org/presentationml/2006/main">
   <p:cSld>
     <p:bg>
       <p:bgPr>
@@ -6619,7 +6707,14 @@
         <p:cNvGrpSpPr/>
         <p:nvPr/>
       </p:nvGrpSpPr>
-      <p:grpSpPr/>
+      <p:grpSpPr>
+        <a:xfrm>
+          <a:off x="0" y="0"/>
+          <a:ext cx="0" cy="0"/>
+          <a:chOff x="0" y="0"/>
+          <a:chExt cx="0" cy="0"/>
+        </a:xfrm>
+      </p:grpSpPr>
       <p:sp>
         <p:nvSpPr>
           <p:cNvPr id="2" name="TextBox 1"/>
@@ -6732,6 +6827,7 @@
           <a:lstStyle/>
           <a:p>
             <a:pPr algn="ctr"/>
+            <a:endParaRPr/>
           </a:p>
         </p:txBody>
       </p:sp>
@@ -6754,11 +6850,41 @@
                 <a:tableStyleId>{5C22544A-7EE6-4342-B048-85BDC9FD1C3A}</a:tableStyleId>
               </a:tblPr>
               <a:tblGrid>
-                <a:gridCol w="2057400"/>
-                <a:gridCol w="1508760"/>
-                <a:gridCol w="1508760"/>
-                <a:gridCol w="1508760"/>
-                <a:gridCol w="1508760"/>
+                <a:gridCol w="2057400">
+                  <a:extLst>
+                    <a:ext uri="{9D8B030D-6E8A-4147-A177-3AD203B41FA5}">
+                      <a16:colId xmlns:a16="http://schemas.microsoft.com/office/drawing/2014/main" val="20000"/>
+                    </a:ext>
+                  </a:extLst>
+                </a:gridCol>
+                <a:gridCol w="1508760">
+                  <a:extLst>
+                    <a:ext uri="{9D8B030D-6E8A-4147-A177-3AD203B41FA5}">
+                      <a16:colId xmlns:a16="http://schemas.microsoft.com/office/drawing/2014/main" val="20001"/>
+                    </a:ext>
+                  </a:extLst>
+                </a:gridCol>
+                <a:gridCol w="1508760">
+                  <a:extLst>
+                    <a:ext uri="{9D8B030D-6E8A-4147-A177-3AD203B41FA5}">
+                      <a16:colId xmlns:a16="http://schemas.microsoft.com/office/drawing/2014/main" val="20002"/>
+                    </a:ext>
+                  </a:extLst>
+                </a:gridCol>
+                <a:gridCol w="1508760">
+                  <a:extLst>
+                    <a:ext uri="{9D8B030D-6E8A-4147-A177-3AD203B41FA5}">
+                      <a16:colId xmlns:a16="http://schemas.microsoft.com/office/drawing/2014/main" val="20003"/>
+                    </a:ext>
+                  </a:extLst>
+                </a:gridCol>
+                <a:gridCol w="1508760">
+                  <a:extLst>
+                    <a:ext uri="{9D8B030D-6E8A-4147-A177-3AD203B41FA5}">
+                      <a16:colId xmlns:a16="http://schemas.microsoft.com/office/drawing/2014/main" val="20004"/>
+                    </a:ext>
+                  </a:extLst>
+                </a:gridCol>
               </a:tblGrid>
               <a:tr h="438912">
                 <a:tc>
@@ -6876,6 +7002,11 @@
                     </a:solidFill>
                   </a:tcPr>
                 </a:tc>
+                <a:extLst>
+                  <a:ext uri="{0D108BD9-81ED-4DB2-BD59-A6C34878D82A}">
+                    <a16:rowId xmlns:a16="http://schemas.microsoft.com/office/drawing/2014/main" val="10000"/>
+                  </a:ext>
+                </a:extLst>
               </a:tr>
               <a:tr h="438912">
                 <a:tc>
@@ -6993,6 +7124,11 @@
                     </a:solidFill>
                   </a:tcPr>
                 </a:tc>
+                <a:extLst>
+                  <a:ext uri="{0D108BD9-81ED-4DB2-BD59-A6C34878D82A}">
+                    <a16:rowId xmlns:a16="http://schemas.microsoft.com/office/drawing/2014/main" val="10001"/>
+                  </a:ext>
+                </a:extLst>
               </a:tr>
               <a:tr h="438912">
                 <a:tc>
@@ -7110,6 +7246,11 @@
                     </a:solidFill>
                   </a:tcPr>
                 </a:tc>
+                <a:extLst>
+                  <a:ext uri="{0D108BD9-81ED-4DB2-BD59-A6C34878D82A}">
+                    <a16:rowId xmlns:a16="http://schemas.microsoft.com/office/drawing/2014/main" val="10002"/>
+                  </a:ext>
+                </a:extLst>
               </a:tr>
               <a:tr h="438912">
                 <a:tc>
@@ -7227,6 +7368,11 @@
                     </a:solidFill>
                   </a:tcPr>
                 </a:tc>
+                <a:extLst>
+                  <a:ext uri="{0D108BD9-81ED-4DB2-BD59-A6C34878D82A}">
+                    <a16:rowId xmlns:a16="http://schemas.microsoft.com/office/drawing/2014/main" val="10003"/>
+                  </a:ext>
+                </a:extLst>
               </a:tr>
               <a:tr h="438912">
                 <a:tc>
@@ -7344,6 +7490,11 @@
                     </a:solidFill>
                   </a:tcPr>
                 </a:tc>
+                <a:extLst>
+                  <a:ext uri="{0D108BD9-81ED-4DB2-BD59-A6C34878D82A}">
+                    <a16:rowId xmlns:a16="http://schemas.microsoft.com/office/drawing/2014/main" val="10004"/>
+                  </a:ext>
+                </a:extLst>
               </a:tr>
             </a:tbl>
           </a:graphicData>
@@ -7391,6 +7542,7 @@
           <a:lstStyle/>
           <a:p>
             <a:pPr algn="ctr"/>
+            <a:endParaRPr/>
           </a:p>
         </p:txBody>
       </p:sp>
@@ -7436,6 +7588,7 @@
           <a:lstStyle/>
           <a:p>
             <a:pPr algn="ctr"/>
+            <a:endParaRPr/>
           </a:p>
         </p:txBody>
       </p:sp>
@@ -7554,6 +7707,7 @@
           <a:lstStyle/>
           <a:p>
             <a:pPr algn="ctr"/>
+            <a:endParaRPr/>
           </a:p>
         </p:txBody>
       </p:sp>
@@ -7599,6 +7753,7 @@
           <a:lstStyle/>
           <a:p>
             <a:pPr algn="ctr"/>
+            <a:endParaRPr/>
           </a:p>
         </p:txBody>
       </p:sp>
@@ -7754,7 +7909,7 @@
 </file>
 
 <file path=ppt/slides/slide7.xml><?xml version="1.0" encoding="utf-8"?>
-<p:sld xmlns:a="http://schemas.openxmlformats.org/drawingml/2006/main" xmlns:p="http://schemas.openxmlformats.org/presentationml/2006/main" xmlns:r="http://schemas.openxmlformats.org/officeDocument/2006/relationships">
+<p:sld xmlns:a="http://schemas.openxmlformats.org/drawingml/2006/main" xmlns:r="http://schemas.openxmlformats.org/officeDocument/2006/relationships" xmlns:p="http://schemas.openxmlformats.org/presentationml/2006/main">
   <p:cSld>
     <p:bg>
       <p:bgPr>
@@ -7770,7 +7925,14 @@
         <p:cNvGrpSpPr/>
         <p:nvPr/>
       </p:nvGrpSpPr>
-      <p:grpSpPr/>
+      <p:grpSpPr>
+        <a:xfrm>
+          <a:off x="0" y="0"/>
+          <a:ext cx="0" cy="0"/>
+          <a:chOff x="0" y="0"/>
+          <a:chExt cx="0" cy="0"/>
+        </a:xfrm>
+      </p:grpSpPr>
       <p:sp>
         <p:nvSpPr>
           <p:cNvPr id="2" name="TextBox 1"/>
@@ -7883,6 +8045,7 @@
           <a:lstStyle/>
           <a:p>
             <a:pPr algn="ctr"/>
+            <a:endParaRPr/>
           </a:p>
         </p:txBody>
       </p:sp>
@@ -7928,6 +8091,7 @@
           <a:lstStyle/>
           <a:p>
             <a:pPr algn="ctr"/>
+            <a:endParaRPr/>
           </a:p>
         </p:txBody>
       </p:sp>
@@ -7973,6 +8137,7 @@
           <a:lstStyle/>
           <a:p>
             <a:pPr algn="ctr"/>
+            <a:endParaRPr/>
           </a:p>
         </p:txBody>
       </p:sp>
@@ -8151,6 +8316,7 @@
           <a:lstStyle/>
           <a:p>
             <a:pPr algn="ctr"/>
+            <a:endParaRPr/>
           </a:p>
         </p:txBody>
       </p:sp>
@@ -8196,6 +8362,7 @@
           <a:lstStyle/>
           <a:p>
             <a:pPr algn="ctr"/>
+            <a:endParaRPr/>
           </a:p>
         </p:txBody>
       </p:sp>
@@ -8411,7 +8578,7 @@
 </file>
 
 <file path=ppt/slides/slide8.xml><?xml version="1.0" encoding="utf-8"?>
-<p:sld xmlns:a="http://schemas.openxmlformats.org/drawingml/2006/main" xmlns:p="http://schemas.openxmlformats.org/presentationml/2006/main" xmlns:r="http://schemas.openxmlformats.org/officeDocument/2006/relationships">
+<p:sld xmlns:a="http://schemas.openxmlformats.org/drawingml/2006/main" xmlns:r="http://schemas.openxmlformats.org/officeDocument/2006/relationships" xmlns:p="http://schemas.openxmlformats.org/presentationml/2006/main">
   <p:cSld>
     <p:bg>
       <p:bgPr>
@@ -8427,7 +8594,14 @@
         <p:cNvGrpSpPr/>
         <p:nvPr/>
       </p:nvGrpSpPr>
-      <p:grpSpPr/>
+      <p:grpSpPr>
+        <a:xfrm>
+          <a:off x="0" y="0"/>
+          <a:ext cx="0" cy="0"/>
+          <a:chOff x="0" y="0"/>
+          <a:chExt cx="0" cy="0"/>
+        </a:xfrm>
+      </p:grpSpPr>
       <p:sp>
         <p:nvSpPr>
           <p:cNvPr id="2" name="TextBox 1"/>
@@ -8540,6 +8714,7 @@
           <a:lstStyle/>
           <a:p>
             <a:pPr algn="ctr"/>
+            <a:endParaRPr/>
           </a:p>
         </p:txBody>
       </p:sp>
@@ -8585,6 +8760,7 @@
           <a:lstStyle/>
           <a:p>
             <a:pPr algn="ctr"/>
+            <a:endParaRPr/>
           </a:p>
         </p:txBody>
       </p:sp>
@@ -8632,7 +8808,7 @@
         <p:spPr>
           <a:xfrm>
             <a:off x="896112" y="2176272"/>
-            <a:ext cx="10424160" cy="658368"/>
+            <a:ext cx="10869194" cy="707886"/>
           </a:xfrm>
           <a:prstGeom prst="rect">
             <a:avLst/>
@@ -8653,7 +8829,22 @@
               </a:defRPr>
             </a:pPr>
             <a:r>
-              <a:t>This is a meaningful contribution: it identifies a real pitfall in multimodal DPO and proposes a simple, effective correction.</a:t>
+              <a:rPr dirty="0"/>
+              <a:t>This is a meaningful contribution: it identifies a real pitfall in multimodal DPO and proposes a simple, </a:t>
+            </a:r>
+            <a:endParaRPr lang="en-US" dirty="0"/>
+          </a:p>
+          <a:p>
+            <a:pPr algn="l">
+              <a:defRPr sz="2000" b="1">
+                <a:solidFill>
+                  <a:srgbClr val="162236"/>
+                </a:solidFill>
+              </a:defRPr>
+            </a:pPr>
+            <a:r>
+              <a:rPr dirty="0"/>
+              <a:t>effective correction.</a:t>
             </a:r>
           </a:p>
         </p:txBody>
@@ -8700,6 +8891,7 @@
           <a:lstStyle/>
           <a:p>
             <a:pPr algn="ctr"/>
+            <a:endParaRPr/>
           </a:p>
         </p:txBody>
       </p:sp>
@@ -8745,6 +8937,7 @@
           <a:lstStyle/>
           <a:p>
             <a:pPr algn="ctr"/>
+            <a:endParaRPr/>
           </a:p>
         </p:txBody>
       </p:sp>
@@ -8893,6 +9086,7 @@
           <a:lstStyle/>
           <a:p>
             <a:pPr algn="ctr"/>
+            <a:endParaRPr/>
           </a:p>
         </p:txBody>
       </p:sp>
@@ -8938,6 +9132,7 @@
           <a:lstStyle/>
           <a:p>
             <a:pPr algn="ctr"/>
+            <a:endParaRPr/>
           </a:p>
         </p:txBody>
       </p:sp>
@@ -9086,6 +9281,7 @@
           <a:lstStyle/>
           <a:p>
             <a:pPr algn="ctr"/>
+            <a:endParaRPr/>
           </a:p>
         </p:txBody>
       </p:sp>
@@ -9131,6 +9327,7 @@
           <a:lstStyle/>
           <a:p>
             <a:pPr algn="ctr"/>
+            <a:endParaRPr/>
           </a:p>
         </p:txBody>
       </p:sp>

</xml_diff>